<commit_message>
Show opened sources on every room, chapter, and download.
Replace the root redirect stub with a Contact Path page whose canonical URL is absolute, and re-record the architect clips so they speak the Contact Path script.

Co-authored-by: CYPHER0X9 <cipher0x9@users.noreply.github.com>
</commit_message>
<xml_diff>
--- a/campus/downloads/bridge-notes.pptx
+++ b/campus/downloads/bridge-notes.pptx
@@ -404,25 +404,49 @@
           <a:p>
             <a:r>
               <a:rPr lang="en-US" sz="1600" dirty="0"/>
-              <a:t>Opened NiCE help pages are linked from the HTML sheets.</a:t>
-            </a:r>
-          </a:p>
-          <a:p>
-            <a:r>
-              <a:rPr lang="en-US" sz="1600" dirty="0"/>
-              <a:t>A direct open that failed is marked confirm and has no URL.</a:t>
+              <a:t>Third-Party ACDs https://help.nicecxone.com/content/workforcemanagement/third-party%20acds.htm last checked 2026-10</a:t>
+            </a:r>
+          </a:p>
+          <a:p>
+            <a:r>
+              <a:rPr lang="en-US" sz="1600" dirty="0"/>
+              <a:t>Prepare Genesys T-Lib with SIPREC https://help.nicecxone.com/content/cxoneopenthirdparty/genesyssipserverandsiprec.htm last checked 2026-10</a:t>
+            </a:r>
+          </a:p>
+          <a:p>
+            <a:r>
+              <a:rPr lang="en-US" sz="1600" dirty="0"/>
+              <a:t>Amazon Connect https://help.nicecxone.com/content/integratedsolutions/amazonconnect/amazon%20connect.htm last checked 2026-10</a:t>
+            </a:r>
+          </a:p>
+          <a:p>
+            <a:r>
+              <a:rPr lang="en-US" sz="1600" dirty="0"/>
+              <a:t>Customer Integration Guide - Amazon Connect https://help.nicecxone.com/content/workforcemanagement/customerintegrationguideamazonconnect.htm last checked 2026-10</a:t>
+            </a:r>
+          </a:p>
+          <a:p>
+            <a:r>
+              <a:rPr lang="en-US" sz="1600" dirty="0"/>
+              <a:t>Five9 bridge — confirm</a:t>
+            </a:r>
+          </a:p>
+          <a:p>
+            <a:r>
+              <a:rPr lang="en-US" sz="1600" dirty="0"/>
+              <a:t>Webex Contact Center bridge — confirm</a:t>
+            </a:r>
+          </a:p>
+          <a:p>
+            <a:r>
+              <a:rPr lang="en-US" sz="1600" dirty="0"/>
+              <a:t>Last checked 2026-10. A confirm row has no URL.</a:t>
             </a:r>
           </a:p>
           <a:p>
             <a:r>
               <a:rPr lang="en-US" sz="1600" dirty="0"/>
               <a:t>https://cyphermonkeylabs.com · https://github.com/CypherMonkeyLabs · https://linktr.ee/cyphermonkey · https://github.com/CypherMonkeyLabs/nice-cxone-lab-free-university-mesmerizing</a:t>
-            </a:r>
-          </a:p>
-          <a:p>
-            <a:r>
-              <a:rPr lang="en-US" sz="1600" dirty="0"/>
-              <a:t>Last checked 2026-10.</a:t>
             </a:r>
           </a:p>
         </p:txBody>

</xml_diff>